<commit_message>
Add presenter and supervisor to presentation cover
</commit_message>
<xml_diff>
--- a/deliverables/Social-Ear-Project-Overview.pptx
+++ b/deliverables/Social-Ear-Project-Overview.pptx
@@ -2,30 +2,30 @@
 <file path=ppt/presentation.xml><?xml version="1.0" encoding="utf-8"?>
 <p:presentation xmlns:p="http://schemas.openxmlformats.org/presentationml/2006/main">
   <p:sldMasterIdLst>
-    <p:sldMasterId xmlns:r="http://schemas.openxmlformats.org/officeDocument/2006/relationships" id="2147483648" r:id="Rb2d541301dab4eb6"/>
+    <p:sldMasterId xmlns:r="http://schemas.openxmlformats.org/officeDocument/2006/relationships" id="2147483648" r:id="R451c0d6260624ae8"/>
   </p:sldMasterIdLst>
   <p:notesMasterIdLst>
-    <p:notesMasterId xmlns:r="http://schemas.openxmlformats.org/officeDocument/2006/relationships" r:id="R9e1addee7e7e4a4a"/>
+    <p:notesMasterId xmlns:r="http://schemas.openxmlformats.org/officeDocument/2006/relationships" r:id="R41a1a7985b294417"/>
   </p:notesMasterIdLst>
   <p:sldIdLst>
-    <p:sldId xmlns:r="http://schemas.openxmlformats.org/officeDocument/2006/relationships" id="256" r:id="Re7e7f7fb665b4354"/>
-    <p:sldId xmlns:r="http://schemas.openxmlformats.org/officeDocument/2006/relationships" id="257" r:id="R0a7c4b7b2c6547b5"/>
-    <p:sldId xmlns:r="http://schemas.openxmlformats.org/officeDocument/2006/relationships" id="258" r:id="Rbd74d907e59a44be"/>
-    <p:sldId xmlns:r="http://schemas.openxmlformats.org/officeDocument/2006/relationships" id="259" r:id="Rc6ec1784e5474d7b"/>
-    <p:sldId xmlns:r="http://schemas.openxmlformats.org/officeDocument/2006/relationships" id="260" r:id="R9cf7feac1b7c40fd"/>
-    <p:sldId xmlns:r="http://schemas.openxmlformats.org/officeDocument/2006/relationships" id="261" r:id="R5cad64e1a2b447f4"/>
-    <p:sldId xmlns:r="http://schemas.openxmlformats.org/officeDocument/2006/relationships" id="262" r:id="Rf8efd4cb76e94b64"/>
-    <p:sldId xmlns:r="http://schemas.openxmlformats.org/officeDocument/2006/relationships" id="263" r:id="Rbf06d8c53a0a4f95"/>
-    <p:sldId xmlns:r="http://schemas.openxmlformats.org/officeDocument/2006/relationships" id="264" r:id="Rfa7d05d8f53d4206"/>
-    <p:sldId xmlns:r="http://schemas.openxmlformats.org/officeDocument/2006/relationships" id="265" r:id="R98d8f1253267438c"/>
-    <p:sldId xmlns:r="http://schemas.openxmlformats.org/officeDocument/2006/relationships" id="266" r:id="R3b6720b6249d45a1"/>
-    <p:sldId xmlns:r="http://schemas.openxmlformats.org/officeDocument/2006/relationships" id="267" r:id="Rbb8e1c2a7af04cd2"/>
-    <p:sldId xmlns:r="http://schemas.openxmlformats.org/officeDocument/2006/relationships" id="268" r:id="Rb9485253f3904c6c"/>
-    <p:sldId xmlns:r="http://schemas.openxmlformats.org/officeDocument/2006/relationships" id="269" r:id="R67e6849c38964875"/>
-    <p:sldId xmlns:r="http://schemas.openxmlformats.org/officeDocument/2006/relationships" id="270" r:id="R95c0bcad0ef6481b"/>
-    <p:sldId xmlns:r="http://schemas.openxmlformats.org/officeDocument/2006/relationships" id="271" r:id="R965b77084da64de4"/>
-    <p:sldId xmlns:r="http://schemas.openxmlformats.org/officeDocument/2006/relationships" id="272" r:id="R2b9eb22701294520"/>
-    <p:sldId xmlns:r="http://schemas.openxmlformats.org/officeDocument/2006/relationships" id="273" r:id="Rc9527b21d1824458"/>
+    <p:sldId xmlns:r="http://schemas.openxmlformats.org/officeDocument/2006/relationships" id="256" r:id="R469ab0343cb94bd8"/>
+    <p:sldId xmlns:r="http://schemas.openxmlformats.org/officeDocument/2006/relationships" id="257" r:id="Rc900b03799eb4fcc"/>
+    <p:sldId xmlns:r="http://schemas.openxmlformats.org/officeDocument/2006/relationships" id="258" r:id="R3bce697e10f44b9f"/>
+    <p:sldId xmlns:r="http://schemas.openxmlformats.org/officeDocument/2006/relationships" id="259" r:id="R185e442264f1405c"/>
+    <p:sldId xmlns:r="http://schemas.openxmlformats.org/officeDocument/2006/relationships" id="260" r:id="R48f2907fa3f74b13"/>
+    <p:sldId xmlns:r="http://schemas.openxmlformats.org/officeDocument/2006/relationships" id="261" r:id="R28bfaf47a1594817"/>
+    <p:sldId xmlns:r="http://schemas.openxmlformats.org/officeDocument/2006/relationships" id="262" r:id="Ra5146fd7bf3e458a"/>
+    <p:sldId xmlns:r="http://schemas.openxmlformats.org/officeDocument/2006/relationships" id="263" r:id="R66198c78d95046a2"/>
+    <p:sldId xmlns:r="http://schemas.openxmlformats.org/officeDocument/2006/relationships" id="264" r:id="Rcf70d597fb864dd0"/>
+    <p:sldId xmlns:r="http://schemas.openxmlformats.org/officeDocument/2006/relationships" id="265" r:id="Rd1b94d717fa84ac4"/>
+    <p:sldId xmlns:r="http://schemas.openxmlformats.org/officeDocument/2006/relationships" id="266" r:id="R340f79c2d10b42aa"/>
+    <p:sldId xmlns:r="http://schemas.openxmlformats.org/officeDocument/2006/relationships" id="267" r:id="R358f297fad0b402d"/>
+    <p:sldId xmlns:r="http://schemas.openxmlformats.org/officeDocument/2006/relationships" id="268" r:id="R819e1ddb228949a7"/>
+    <p:sldId xmlns:r="http://schemas.openxmlformats.org/officeDocument/2006/relationships" id="269" r:id="Rc0611134902d4d3a"/>
+    <p:sldId xmlns:r="http://schemas.openxmlformats.org/officeDocument/2006/relationships" id="270" r:id="Rbbe4b9a2ca6449e1"/>
+    <p:sldId xmlns:r="http://schemas.openxmlformats.org/officeDocument/2006/relationships" id="271" r:id="R0838fd2aad0c4e3e"/>
+    <p:sldId xmlns:r="http://schemas.openxmlformats.org/officeDocument/2006/relationships" id="272" r:id="Rbb5f5351a7714b78"/>
+    <p:sldId xmlns:r="http://schemas.openxmlformats.org/officeDocument/2006/relationships" id="273" r:id="R895171a76df34d03"/>
   </p:sldIdLst>
   <p:sldSz cx="12192000" cy="6858000"/>
   <p:notesSz cx="6858000" cy="9144000"/>
@@ -4397,12 +4397,12 @@
   </p:cSld>
   <p:clrMap bg1="lt1" tx1="dk1" bg2="lt2" tx2="dk2" accent1="accent1" accent2="accent2" accent3="accent3" accent4="accent4" accent5="accent5" accent6="accent6" hlink="hlink" folHlink="folHlink"/>
   <p:sldLayoutIdLst>
-    <p:sldLayoutId xmlns:r="http://schemas.openxmlformats.org/officeDocument/2006/relationships" id="2147483649" r:id="R996a296ed40342d7"/>
-    <p:sldLayoutId xmlns:r="http://schemas.openxmlformats.org/officeDocument/2006/relationships" id="2147483650" r:id="R410e476793fa4724"/>
-    <p:sldLayoutId xmlns:r="http://schemas.openxmlformats.org/officeDocument/2006/relationships" id="2147483651" r:id="Rd0d0af042e6c45a5"/>
-    <p:sldLayoutId xmlns:r="http://schemas.openxmlformats.org/officeDocument/2006/relationships" id="2147483652" r:id="R6297f0f617ad4cdb"/>
-    <p:sldLayoutId xmlns:r="http://schemas.openxmlformats.org/officeDocument/2006/relationships" id="2147483653" r:id="R1ba25cd44e8147ac"/>
-    <p:sldLayoutId xmlns:r="http://schemas.openxmlformats.org/officeDocument/2006/relationships" id="2147483654" r:id="R298646db728e40a9"/>
+    <p:sldLayoutId xmlns:r="http://schemas.openxmlformats.org/officeDocument/2006/relationships" id="2147483649" r:id="Rc2eb913a625e442d"/>
+    <p:sldLayoutId xmlns:r="http://schemas.openxmlformats.org/officeDocument/2006/relationships" id="2147483650" r:id="R3eef67ab51c84389"/>
+    <p:sldLayoutId xmlns:r="http://schemas.openxmlformats.org/officeDocument/2006/relationships" id="2147483651" r:id="R1a4b5f6a039c4dea"/>
+    <p:sldLayoutId xmlns:r="http://schemas.openxmlformats.org/officeDocument/2006/relationships" id="2147483652" r:id="R031ff943ea0b40f4"/>
+    <p:sldLayoutId xmlns:r="http://schemas.openxmlformats.org/officeDocument/2006/relationships" id="2147483653" r:id="R66512678df4149fc"/>
+    <p:sldLayoutId xmlns:r="http://schemas.openxmlformats.org/officeDocument/2006/relationships" id="2147483654" r:id="Rfc44824c1b6448e1"/>
   </p:sldLayoutIdLst>
   <p:txStyles>
     <p:titleStyle>
@@ -5455,7 +5455,7 @@
         </p:nvSpPr>
         <p:spPr>
           <a:xfrm xmlns:a="http://schemas.openxmlformats.org/drawingml/2006/main">
-            <a:off x="742950" y="5553075"/>
+            <a:off x="742950" y="5867400"/>
             <a:ext cx="10287000" cy="428625"/>
           </a:xfrm>
           <a:prstGeom xmlns:a="http://schemas.openxmlformats.org/drawingml/2006/main" prst="rect">
@@ -5611,7 +5611,7 @@
         </p:nvSpPr>
         <p:spPr>
           <a:xfrm xmlns:a="http://schemas.openxmlformats.org/drawingml/2006/main">
-            <a:off x="742950" y="6124575"/>
+            <a:off x="742950" y="6334125"/>
             <a:ext cx="7620000" cy="266700"/>
           </a:xfrm>
           <a:prstGeom xmlns:a="http://schemas.openxmlformats.org/drawingml/2006/main" prst="rect">
@@ -5747,6 +5747,318 @@
                 <a:cs typeface="Arial"/>
               </a:rPr>
               <a:t>20 October 2026</a:t>
+            </a:r>
+          </a:p>
+        </p:txBody>
+      </p:sp>
+      <p:sp>
+        <p:nvSpPr>
+          <p:cNvPr id="7" name="">
+            <a:extLst xmlns:a="http://schemas.openxmlformats.org/drawingml/2006/main">
+              <a:ext uri="{FF2B5EF4-FFF2-40B4-BE49-F238E27FC236}">
+                <a16:creationId xmlns:a16="http://schemas.microsoft.com/office/drawing/2014/main" id="{BB9783BD-568E-41D6-A34F-D33D8915C9DA}"/>
+              </a:ext>
+            </a:extLst>
+          </p:cNvPr>
+          <p:cNvSpPr>
+            <a:spLocks xmlns:a="http://schemas.openxmlformats.org/drawingml/2006/main" noGrp="1"/>
+          </p:cNvSpPr>
+          <p:nvPr/>
+        </p:nvSpPr>
+        <p:spPr>
+          <a:xfrm xmlns:a="http://schemas.openxmlformats.org/drawingml/2006/main">
+            <a:off x="742950" y="4867275"/>
+            <a:ext cx="10287000" cy="342900"/>
+          </a:xfrm>
+          <a:prstGeom xmlns:a="http://schemas.openxmlformats.org/drawingml/2006/main" prst="rect">
+            <a:avLst/>
+          </a:prstGeom>
+          <a:noFill xmlns:a="http://schemas.openxmlformats.org/drawingml/2006/main"/>
+          <a:ln xmlns:a="http://schemas.openxmlformats.org/drawingml/2006/main" w="0">
+            <a:noFill/>
+          </a:ln>
+        </p:spPr>
+        <p:txBody>
+          <a:bodyPr xmlns:a="http://schemas.openxmlformats.org/drawingml/2006/main" anchor="t"/>
+          <a:lstStyle xmlns:a="http://schemas.openxmlformats.org/drawingml/2006/main">
+            <a:defPPr>
+              <a:defRPr sz="1875">
+                <a:solidFill>
+                  <a:srgbClr val="FFFFFF"/>
+                </a:solidFill>
+                <a:latin typeface="Arial"/>
+                <a:ea typeface="Arial"/>
+                <a:cs typeface="Arial"/>
+              </a:defRPr>
+            </a:defPPr>
+            <a:lvl1pPr>
+              <a:defRPr sz="1875">
+                <a:solidFill>
+                  <a:srgbClr val="FFFFFF"/>
+                </a:solidFill>
+                <a:latin typeface="Arial"/>
+                <a:ea typeface="Arial"/>
+                <a:cs typeface="Arial"/>
+              </a:defRPr>
+            </a:lvl1pPr>
+            <a:lvl2pPr>
+              <a:defRPr sz="1875">
+                <a:solidFill>
+                  <a:srgbClr val="FFFFFF"/>
+                </a:solidFill>
+                <a:latin typeface="Arial"/>
+                <a:ea typeface="Arial"/>
+                <a:cs typeface="Arial"/>
+              </a:defRPr>
+            </a:lvl2pPr>
+            <a:lvl3pPr>
+              <a:defRPr sz="1875">
+                <a:solidFill>
+                  <a:srgbClr val="FFFFFF"/>
+                </a:solidFill>
+                <a:latin typeface="Arial"/>
+                <a:ea typeface="Arial"/>
+                <a:cs typeface="Arial"/>
+              </a:defRPr>
+            </a:lvl3pPr>
+            <a:lvl4pPr>
+              <a:defRPr sz="1875">
+                <a:solidFill>
+                  <a:srgbClr val="FFFFFF"/>
+                </a:solidFill>
+                <a:latin typeface="Arial"/>
+                <a:ea typeface="Arial"/>
+                <a:cs typeface="Arial"/>
+              </a:defRPr>
+            </a:lvl4pPr>
+            <a:lvl5pPr>
+              <a:defRPr sz="1875">
+                <a:solidFill>
+                  <a:srgbClr val="FFFFFF"/>
+                </a:solidFill>
+                <a:latin typeface="Arial"/>
+                <a:ea typeface="Arial"/>
+                <a:cs typeface="Arial"/>
+              </a:defRPr>
+            </a:lvl5pPr>
+            <a:lvl6pPr>
+              <a:defRPr sz="1875">
+                <a:solidFill>
+                  <a:srgbClr val="FFFFFF"/>
+                </a:solidFill>
+                <a:latin typeface="Arial"/>
+                <a:ea typeface="Arial"/>
+                <a:cs typeface="Arial"/>
+              </a:defRPr>
+            </a:lvl6pPr>
+            <a:lvl7pPr>
+              <a:defRPr sz="1875">
+                <a:solidFill>
+                  <a:srgbClr val="FFFFFF"/>
+                </a:solidFill>
+                <a:latin typeface="Arial"/>
+                <a:ea typeface="Arial"/>
+                <a:cs typeface="Arial"/>
+              </a:defRPr>
+            </a:lvl7pPr>
+            <a:lvl8pPr>
+              <a:defRPr sz="1875">
+                <a:solidFill>
+                  <a:srgbClr val="FFFFFF"/>
+                </a:solidFill>
+                <a:latin typeface="Arial"/>
+                <a:ea typeface="Arial"/>
+                <a:cs typeface="Arial"/>
+              </a:defRPr>
+            </a:lvl8pPr>
+            <a:lvl9pPr>
+              <a:defRPr sz="1875">
+                <a:solidFill>
+                  <a:srgbClr val="FFFFFF"/>
+                </a:solidFill>
+                <a:latin typeface="Arial"/>
+                <a:ea typeface="Arial"/>
+                <a:cs typeface="Arial"/>
+              </a:defRPr>
+            </a:lvl9pPr>
+          </a:lstStyle>
+          <a:p xmlns:a="http://schemas.openxmlformats.org/drawingml/2006/main">
+            <a:pPr>
+              <a:defRPr sz="1875">
+                <a:solidFill>
+                  <a:srgbClr val="FFFFFF"/>
+                </a:solidFill>
+                <a:latin typeface="Arial"/>
+                <a:ea typeface="Arial"/>
+                <a:cs typeface="Arial"/>
+              </a:defRPr>
+            </a:pPr>
+            <a:r>
+              <a:rPr sz="1875">
+                <a:solidFill>
+                  <a:srgbClr val="FFFFFF"/>
+                </a:solidFill>
+                <a:latin typeface="Arial"/>
+                <a:ea typeface="Arial"/>
+                <a:cs typeface="Arial"/>
+              </a:rPr>
+              <a:t>Presented by: Hamza El haddaji</a:t>
+            </a:r>
+          </a:p>
+        </p:txBody>
+      </p:sp>
+      <p:sp>
+        <p:nvSpPr>
+          <p:cNvPr id="8" name="">
+            <a:extLst xmlns:a="http://schemas.openxmlformats.org/drawingml/2006/main">
+              <a:ext uri="{FF2B5EF4-FFF2-40B4-BE49-F238E27FC236}">
+                <a16:creationId xmlns:a16="http://schemas.microsoft.com/office/drawing/2014/main" id="{FE7C5E3E-7A55-4950-A078-87948BAFFD4F}"/>
+              </a:ext>
+            </a:extLst>
+          </p:cNvPr>
+          <p:cNvSpPr>
+            <a:spLocks xmlns:a="http://schemas.openxmlformats.org/drawingml/2006/main" noGrp="1"/>
+          </p:cNvSpPr>
+          <p:nvPr/>
+        </p:nvSpPr>
+        <p:spPr>
+          <a:xfrm xmlns:a="http://schemas.openxmlformats.org/drawingml/2006/main">
+            <a:off x="742950" y="5276850"/>
+            <a:ext cx="10287000" cy="342900"/>
+          </a:xfrm>
+          <a:prstGeom xmlns:a="http://schemas.openxmlformats.org/drawingml/2006/main" prst="rect">
+            <a:avLst/>
+          </a:prstGeom>
+          <a:noFill xmlns:a="http://schemas.openxmlformats.org/drawingml/2006/main"/>
+          <a:ln xmlns:a="http://schemas.openxmlformats.org/drawingml/2006/main" w="0">
+            <a:noFill/>
+          </a:ln>
+        </p:spPr>
+        <p:txBody>
+          <a:bodyPr xmlns:a="http://schemas.openxmlformats.org/drawingml/2006/main" anchor="t"/>
+          <a:lstStyle xmlns:a="http://schemas.openxmlformats.org/drawingml/2006/main">
+            <a:defPPr>
+              <a:defRPr sz="1875">
+                <a:solidFill>
+                  <a:srgbClr val="FFFFFF"/>
+                </a:solidFill>
+                <a:latin typeface="Arial"/>
+                <a:ea typeface="Arial"/>
+                <a:cs typeface="Arial"/>
+              </a:defRPr>
+            </a:defPPr>
+            <a:lvl1pPr>
+              <a:defRPr sz="1875">
+                <a:solidFill>
+                  <a:srgbClr val="FFFFFF"/>
+                </a:solidFill>
+                <a:latin typeface="Arial"/>
+                <a:ea typeface="Arial"/>
+                <a:cs typeface="Arial"/>
+              </a:defRPr>
+            </a:lvl1pPr>
+            <a:lvl2pPr>
+              <a:defRPr sz="1875">
+                <a:solidFill>
+                  <a:srgbClr val="FFFFFF"/>
+                </a:solidFill>
+                <a:latin typeface="Arial"/>
+                <a:ea typeface="Arial"/>
+                <a:cs typeface="Arial"/>
+              </a:defRPr>
+            </a:lvl2pPr>
+            <a:lvl3pPr>
+              <a:defRPr sz="1875">
+                <a:solidFill>
+                  <a:srgbClr val="FFFFFF"/>
+                </a:solidFill>
+                <a:latin typeface="Arial"/>
+                <a:ea typeface="Arial"/>
+                <a:cs typeface="Arial"/>
+              </a:defRPr>
+            </a:lvl3pPr>
+            <a:lvl4pPr>
+              <a:defRPr sz="1875">
+                <a:solidFill>
+                  <a:srgbClr val="FFFFFF"/>
+                </a:solidFill>
+                <a:latin typeface="Arial"/>
+                <a:ea typeface="Arial"/>
+                <a:cs typeface="Arial"/>
+              </a:defRPr>
+            </a:lvl4pPr>
+            <a:lvl5pPr>
+              <a:defRPr sz="1875">
+                <a:solidFill>
+                  <a:srgbClr val="FFFFFF"/>
+                </a:solidFill>
+                <a:latin typeface="Arial"/>
+                <a:ea typeface="Arial"/>
+                <a:cs typeface="Arial"/>
+              </a:defRPr>
+            </a:lvl5pPr>
+            <a:lvl6pPr>
+              <a:defRPr sz="1875">
+                <a:solidFill>
+                  <a:srgbClr val="FFFFFF"/>
+                </a:solidFill>
+                <a:latin typeface="Arial"/>
+                <a:ea typeface="Arial"/>
+                <a:cs typeface="Arial"/>
+              </a:defRPr>
+            </a:lvl6pPr>
+            <a:lvl7pPr>
+              <a:defRPr sz="1875">
+                <a:solidFill>
+                  <a:srgbClr val="FFFFFF"/>
+                </a:solidFill>
+                <a:latin typeface="Arial"/>
+                <a:ea typeface="Arial"/>
+                <a:cs typeface="Arial"/>
+              </a:defRPr>
+            </a:lvl7pPr>
+            <a:lvl8pPr>
+              <a:defRPr sz="1875">
+                <a:solidFill>
+                  <a:srgbClr val="FFFFFF"/>
+                </a:solidFill>
+                <a:latin typeface="Arial"/>
+                <a:ea typeface="Arial"/>
+                <a:cs typeface="Arial"/>
+              </a:defRPr>
+            </a:lvl8pPr>
+            <a:lvl9pPr>
+              <a:defRPr sz="1875">
+                <a:solidFill>
+                  <a:srgbClr val="FFFFFF"/>
+                </a:solidFill>
+                <a:latin typeface="Arial"/>
+                <a:ea typeface="Arial"/>
+                <a:cs typeface="Arial"/>
+              </a:defRPr>
+            </a:lvl9pPr>
+          </a:lstStyle>
+          <a:p xmlns:a="http://schemas.openxmlformats.org/drawingml/2006/main">
+            <a:pPr>
+              <a:defRPr sz="1875">
+                <a:solidFill>
+                  <a:srgbClr val="FFFFFF"/>
+                </a:solidFill>
+                <a:latin typeface="Arial"/>
+                <a:ea typeface="Arial"/>
+                <a:cs typeface="Arial"/>
+              </a:defRPr>
+            </a:pPr>
+            <a:r>
+              <a:rPr sz="1875">
+                <a:solidFill>
+                  <a:srgbClr val="FFFFFF"/>
+                </a:solidFill>
+                <a:latin typeface="Arial"/>
+                <a:ea typeface="Arial"/>
+                <a:cs typeface="Arial"/>
+              </a:rPr>
+              <a:t>Supervisor: Sanaa El filali</a:t>
             </a:r>
           </a:p>
         </p:txBody>
@@ -6263,7 +6575,7 @@
           <p:nvPr/>
         </p:nvPicPr>
         <p:blipFill>
-          <a:blip xmlns:r="http://schemas.openxmlformats.org/officeDocument/2006/relationships" xmlns:a="http://schemas.openxmlformats.org/drawingml/2006/main" r:embed="R5558b0b9aa0b4ceb"/>
+          <a:blip xmlns:r="http://schemas.openxmlformats.org/officeDocument/2006/relationships" xmlns:a="http://schemas.openxmlformats.org/drawingml/2006/main" r:embed="R9b127617808a4724"/>
           <a:stretch xmlns:a="http://schemas.openxmlformats.org/drawingml/2006/main"/>
         </p:blipFill>
         <p:spPr>
@@ -7880,7 +8192,7 @@
           <p:nvPr/>
         </p:nvPicPr>
         <p:blipFill>
-          <a:blip xmlns:r="http://schemas.openxmlformats.org/officeDocument/2006/relationships" xmlns:a="http://schemas.openxmlformats.org/drawingml/2006/main" r:embed="Rd90f6e7398a045b6"/>
+          <a:blip xmlns:r="http://schemas.openxmlformats.org/officeDocument/2006/relationships" xmlns:a="http://schemas.openxmlformats.org/drawingml/2006/main" r:embed="R40def2fef211498e"/>
           <a:stretch xmlns:a="http://schemas.openxmlformats.org/drawingml/2006/main"/>
         </p:blipFill>
         <p:spPr>
@@ -9497,7 +9809,7 @@
           <p:nvPr/>
         </p:nvPicPr>
         <p:blipFill>
-          <a:blip xmlns:r="http://schemas.openxmlformats.org/officeDocument/2006/relationships" xmlns:a="http://schemas.openxmlformats.org/drawingml/2006/main" r:embed="R7ccc906981e848ec"/>
+          <a:blip xmlns:r="http://schemas.openxmlformats.org/officeDocument/2006/relationships" xmlns:a="http://schemas.openxmlformats.org/drawingml/2006/main" r:embed="Ra480188bc4204089"/>
           <a:stretch xmlns:a="http://schemas.openxmlformats.org/drawingml/2006/main"/>
         </p:blipFill>
         <p:spPr>
@@ -13292,7 +13604,7 @@
           <p:nvPr/>
         </p:nvPicPr>
         <p:blipFill>
-          <a:blip xmlns:r="http://schemas.openxmlformats.org/officeDocument/2006/relationships" xmlns:a="http://schemas.openxmlformats.org/drawingml/2006/main" r:embed="Raa33ef5bd57740b3"/>
+          <a:blip xmlns:r="http://schemas.openxmlformats.org/officeDocument/2006/relationships" xmlns:a="http://schemas.openxmlformats.org/drawingml/2006/main" r:embed="R1a80f36f2b2b4577"/>
           <a:stretch xmlns:a="http://schemas.openxmlformats.org/drawingml/2006/main"/>
         </p:blipFill>
         <p:spPr>
@@ -19181,7 +19493,7 @@
                 <a:latin typeface="Arial"/>
                 <a:ea typeface="Arial"/>
                 <a:cs typeface="Arial"/>
-                <a:hlinkClick xmlns:r="http://schemas.openxmlformats.org/officeDocument/2006/relationships" r:id="Rb17241ad8bd54b44"/>
+                <a:hlinkClick xmlns:r="http://schemas.openxmlformats.org/officeDocument/2006/relationships" r:id="Ra3f345333d9d41cf"/>
               </a:rPr>
               <a:t>github.com/HamzaElhaddaji/social-ear</a:t>
             </a:r>
@@ -26408,7 +26720,7 @@
           <p:nvPr/>
         </p:nvPicPr>
         <p:blipFill>
-          <a:blip xmlns:r="http://schemas.openxmlformats.org/officeDocument/2006/relationships" xmlns:a="http://schemas.openxmlformats.org/drawingml/2006/main" r:embed="Rcac18c66f55349a0"/>
+          <a:blip xmlns:r="http://schemas.openxmlformats.org/officeDocument/2006/relationships" xmlns:a="http://schemas.openxmlformats.org/drawingml/2006/main" r:embed="R0fe1f1391d9e498c"/>
           <a:stretch xmlns:a="http://schemas.openxmlformats.org/drawingml/2006/main"/>
         </p:blipFill>
         <p:spPr>
@@ -28025,7 +28337,7 @@
           <p:nvPr/>
         </p:nvPicPr>
         <p:blipFill>
-          <a:blip xmlns:r="http://schemas.openxmlformats.org/officeDocument/2006/relationships" xmlns:a="http://schemas.openxmlformats.org/drawingml/2006/main" r:embed="Rcc7a77380b65421d"/>
+          <a:blip xmlns:r="http://schemas.openxmlformats.org/officeDocument/2006/relationships" xmlns:a="http://schemas.openxmlformats.org/drawingml/2006/main" r:embed="Rcbe13ad1fc1a474b"/>
           <a:stretch xmlns:a="http://schemas.openxmlformats.org/drawingml/2006/main"/>
         </p:blipFill>
         <p:spPr>
@@ -31254,7 +31566,7 @@
           <p:nvPr/>
         </p:nvPicPr>
         <p:blipFill>
-          <a:blip xmlns:r="http://schemas.openxmlformats.org/officeDocument/2006/relationships" xmlns:a="http://schemas.openxmlformats.org/drawingml/2006/main" r:embed="R9e3999e468394be1"/>
+          <a:blip xmlns:r="http://schemas.openxmlformats.org/officeDocument/2006/relationships" xmlns:a="http://schemas.openxmlformats.org/drawingml/2006/main" r:embed="Rccdfae9088414341"/>
           <a:stretch xmlns:a="http://schemas.openxmlformats.org/drawingml/2006/main"/>
         </p:blipFill>
         <p:spPr>
@@ -32871,7 +33183,7 @@
           <p:nvPr/>
         </p:nvPicPr>
         <p:blipFill>
-          <a:blip xmlns:r="http://schemas.openxmlformats.org/officeDocument/2006/relationships" xmlns:a="http://schemas.openxmlformats.org/drawingml/2006/main" r:embed="Rb9f131226d0a46e0"/>
+          <a:blip xmlns:r="http://schemas.openxmlformats.org/officeDocument/2006/relationships" xmlns:a="http://schemas.openxmlformats.org/drawingml/2006/main" r:embed="R5e3c9b7ece0c4d20"/>
           <a:stretch xmlns:a="http://schemas.openxmlformats.org/drawingml/2006/main"/>
         </p:blipFill>
         <p:spPr>

</xml_diff>